<commit_message>
small changes to ppt
</commit_message>
<xml_diff>
--- a/pitch-deck/pitch1.pptx
+++ b/pitch-deck/pitch1.pptx
@@ -109,6 +109,11 @@
       </a:defRPr>
     </a:lvl9pPr>
   </p:defaultTextStyle>
+  <p:extLst>
+    <p:ext uri="{EFAFB233-063F-42B5-8137-9DF3F51BA10A}">
+      <p15:sldGuideLst xmlns:p15="http://schemas.microsoft.com/office/powerpoint/2012/main"/>
+    </p:ext>
+  </p:extLst>
 </p:presentation>
 </file>
 
@@ -3512,8 +3517,8 @@
         </p:blipFill>
         <p:spPr>
           <a:xfrm>
-            <a:off x="20" y="1282"/>
-            <a:ext cx="12191980" cy="6856718"/>
+            <a:off x="-1839412" y="-594143"/>
+            <a:ext cx="14938723" cy="8401474"/>
           </a:xfrm>
           <a:prstGeom prst="rect">
             <a:avLst/>

</xml_diff>